<commit_message>
prepared for 2nd workshop
</commit_message>
<xml_diff>
--- a/Change Detection Task.pptx
+++ b/Change Detection Task.pptx
@@ -8,7 +8,7 @@
     <p:sldId id="256" r:id="rId2"/>
     <p:sldId id="257" r:id="rId3"/>
     <p:sldId id="259" r:id="rId4"/>
-    <p:sldId id="260" r:id="rId5"/>
+    <p:sldId id="261" r:id="rId5"/>
   </p:sldIdLst>
   <p:sldSz cx="12192000" cy="6858000"/>
   <p:notesSz cx="6858000" cy="9144000"/>
@@ -264,7 +264,7 @@
           <a:p>
             <a:fld id="{A7DB4980-9DFA-7D40-AE12-CBAAE4A971FE}" type="datetimeFigureOut">
               <a:rPr lang="en-US" smtClean="0"/>
-              <a:t>3/3/25</a:t>
+              <a:t>3/24/25</a:t>
             </a:fld>
             <a:endParaRPr lang="en-US"/>
           </a:p>
@@ -464,7 +464,7 @@
           <a:p>
             <a:fld id="{A7DB4980-9DFA-7D40-AE12-CBAAE4A971FE}" type="datetimeFigureOut">
               <a:rPr lang="en-US" smtClean="0"/>
-              <a:t>3/3/25</a:t>
+              <a:t>3/24/25</a:t>
             </a:fld>
             <a:endParaRPr lang="en-US"/>
           </a:p>
@@ -674,7 +674,7 @@
           <a:p>
             <a:fld id="{A7DB4980-9DFA-7D40-AE12-CBAAE4A971FE}" type="datetimeFigureOut">
               <a:rPr lang="en-US" smtClean="0"/>
-              <a:t>3/3/25</a:t>
+              <a:t>3/24/25</a:t>
             </a:fld>
             <a:endParaRPr lang="en-US"/>
           </a:p>
@@ -874,7 +874,7 @@
           <a:p>
             <a:fld id="{A7DB4980-9DFA-7D40-AE12-CBAAE4A971FE}" type="datetimeFigureOut">
               <a:rPr lang="en-US" smtClean="0"/>
-              <a:t>3/3/25</a:t>
+              <a:t>3/24/25</a:t>
             </a:fld>
             <a:endParaRPr lang="en-US"/>
           </a:p>
@@ -1150,7 +1150,7 @@
           <a:p>
             <a:fld id="{A7DB4980-9DFA-7D40-AE12-CBAAE4A971FE}" type="datetimeFigureOut">
               <a:rPr lang="en-US" smtClean="0"/>
-              <a:t>3/3/25</a:t>
+              <a:t>3/24/25</a:t>
             </a:fld>
             <a:endParaRPr lang="en-US"/>
           </a:p>
@@ -1418,7 +1418,7 @@
           <a:p>
             <a:fld id="{A7DB4980-9DFA-7D40-AE12-CBAAE4A971FE}" type="datetimeFigureOut">
               <a:rPr lang="en-US" smtClean="0"/>
-              <a:t>3/3/25</a:t>
+              <a:t>3/24/25</a:t>
             </a:fld>
             <a:endParaRPr lang="en-US"/>
           </a:p>
@@ -1833,7 +1833,7 @@
           <a:p>
             <a:fld id="{A7DB4980-9DFA-7D40-AE12-CBAAE4A971FE}" type="datetimeFigureOut">
               <a:rPr lang="en-US" smtClean="0"/>
-              <a:t>3/3/25</a:t>
+              <a:t>3/24/25</a:t>
             </a:fld>
             <a:endParaRPr lang="en-US"/>
           </a:p>
@@ -1975,7 +1975,7 @@
           <a:p>
             <a:fld id="{A7DB4980-9DFA-7D40-AE12-CBAAE4A971FE}" type="datetimeFigureOut">
               <a:rPr lang="en-US" smtClean="0"/>
-              <a:t>3/3/25</a:t>
+              <a:t>3/24/25</a:t>
             </a:fld>
             <a:endParaRPr lang="en-US"/>
           </a:p>
@@ -2088,7 +2088,7 @@
           <a:p>
             <a:fld id="{A7DB4980-9DFA-7D40-AE12-CBAAE4A971FE}" type="datetimeFigureOut">
               <a:rPr lang="en-US" smtClean="0"/>
-              <a:t>3/3/25</a:t>
+              <a:t>3/24/25</a:t>
             </a:fld>
             <a:endParaRPr lang="en-US"/>
           </a:p>
@@ -2401,7 +2401,7 @@
           <a:p>
             <a:fld id="{A7DB4980-9DFA-7D40-AE12-CBAAE4A971FE}" type="datetimeFigureOut">
               <a:rPr lang="en-US" smtClean="0"/>
-              <a:t>3/3/25</a:t>
+              <a:t>3/24/25</a:t>
             </a:fld>
             <a:endParaRPr lang="en-US"/>
           </a:p>
@@ -2690,7 +2690,7 @@
           <a:p>
             <a:fld id="{A7DB4980-9DFA-7D40-AE12-CBAAE4A971FE}" type="datetimeFigureOut">
               <a:rPr lang="en-US" smtClean="0"/>
-              <a:t>3/3/25</a:t>
+              <a:t>3/24/25</a:t>
             </a:fld>
             <a:endParaRPr lang="en-US"/>
           </a:p>
@@ -2933,7 +2933,7 @@
           <a:p>
             <a:fld id="{A7DB4980-9DFA-7D40-AE12-CBAAE4A971FE}" type="datetimeFigureOut">
               <a:rPr lang="en-US" smtClean="0"/>
-              <a:t>3/3/25</a:t>
+              <a:t>3/24/25</a:t>
             </a:fld>
             <a:endParaRPr lang="en-US"/>
           </a:p>
@@ -4633,11 +4633,11 @@
           <a:p>
             <a:r>
               <a:rPr lang="en-US" sz="2000" i="1" dirty="0"/>
-              <a:t>D</a:t>
+              <a:t>m</a:t>
             </a:r>
             <a:r>
               <a:rPr lang="en-US" sz="2000" dirty="0"/>
-              <a:t> (detection, probability that study </a:t>
+              <a:t> (probability that study </a:t>
             </a:r>
             <a:r>
               <a:rPr lang="en-US" sz="2000" dirty="0" err="1"/>
@@ -4677,29 +4677,13 @@
             </a:r>
             <a:r>
               <a:rPr lang="en-US" sz="2000" dirty="0"/>
-              <a:t> = study set size. [</a:t>
-            </a:r>
+              <a:t> = study set size. </a:t>
+            </a:r>
+          </a:p>
+          <a:p>
             <a:r>
               <a:rPr lang="en-US" sz="2000" i="1" dirty="0"/>
-              <a:t>D</a:t>
-            </a:r>
-            <a:r>
-              <a:rPr lang="en-US" sz="2000" dirty="0"/>
-              <a:t> is called </a:t>
-            </a:r>
-            <a:r>
-              <a:rPr lang="en-US" sz="2000" i="1" dirty="0"/>
-              <a:t>m</a:t>
-            </a:r>
-            <a:r>
-              <a:rPr lang="en-US" sz="2000" dirty="0"/>
-              <a:t> in code]</a:t>
-            </a:r>
-          </a:p>
-          <a:p>
-            <a:r>
-              <a:rPr lang="en-US" sz="2000" i="1" dirty="0"/>
-              <a:t>G</a:t>
+              <a:t>g</a:t>
             </a:r>
             <a:r>
               <a:rPr lang="en-US" sz="2000" dirty="0"/>
@@ -4746,7 +4730,7 @@
             </a:r>
             <a:r>
               <a:rPr lang="en-US" sz="2000" i="1" dirty="0"/>
-              <a:t>D</a:t>
+              <a:t>m</a:t>
             </a:r>
             <a:r>
               <a:rPr lang="en-US" sz="2000" dirty="0"/>
@@ -4754,7 +4738,7 @@
             </a:r>
             <a:r>
               <a:rPr lang="en-US" sz="2000" i="1" dirty="0"/>
-              <a:t>D</a:t>
+              <a:t>m</a:t>
             </a:r>
             <a:r>
               <a:rPr lang="en-US" sz="2000" dirty="0"/>
@@ -4762,7 +4746,7 @@
             </a:r>
             <a:r>
               <a:rPr lang="en-US" sz="2000" i="1" dirty="0"/>
-              <a:t>G</a:t>
+              <a:t>g</a:t>
             </a:r>
           </a:p>
           <a:p>
@@ -4776,7 +4760,7 @@
             </a:r>
             <a:r>
               <a:rPr lang="en-US" sz="2000" i="1" dirty="0"/>
-              <a:t>D</a:t>
+              <a:t>m</a:t>
             </a:r>
             <a:r>
               <a:rPr lang="en-US" sz="2000" dirty="0"/>
@@ -4784,7 +4768,327 @@
             </a:r>
             <a:r>
               <a:rPr lang="en-US" sz="2000" i="1" dirty="0"/>
-              <a:t>G</a:t>
+              <a:t>g</a:t>
+            </a:r>
+          </a:p>
+        </p:txBody>
+      </p:sp>
+      <p:sp>
+        <p:nvSpPr>
+          <p:cNvPr id="4" name="TextBox 3">
+            <a:extLst>
+              <a:ext uri="{FF2B5EF4-FFF2-40B4-BE49-F238E27FC236}">
+                <a16:creationId xmlns:a16="http://schemas.microsoft.com/office/drawing/2014/main" id="{6057200B-3562-630E-D22F-7C9FD6676814}"/>
+              </a:ext>
+            </a:extLst>
+          </p:cNvPr>
+          <p:cNvSpPr txBox="1"/>
+          <p:nvPr/>
+        </p:nvSpPr>
+        <p:spPr>
+          <a:xfrm>
+            <a:off x="1277678" y="2019532"/>
+            <a:ext cx="393405" cy="461665"/>
+          </a:xfrm>
+          <a:prstGeom prst="rect">
+            <a:avLst/>
+          </a:prstGeom>
+          <a:solidFill>
+            <a:schemeClr val="bg1"/>
+          </a:solidFill>
+        </p:spPr>
+        <p:txBody>
+          <a:bodyPr wrap="square" rtlCol="0">
+            <a:spAutoFit/>
+          </a:bodyPr>
+          <a:lstStyle/>
+          <a:p>
+            <a:pPr algn="ctr"/>
+            <a:r>
+              <a:rPr lang="en-US" sz="2400" i="1" dirty="0"/>
+              <a:t>m</a:t>
+            </a:r>
+          </a:p>
+        </p:txBody>
+      </p:sp>
+      <p:sp>
+        <p:nvSpPr>
+          <p:cNvPr id="9" name="TextBox 8">
+            <a:extLst>
+              <a:ext uri="{FF2B5EF4-FFF2-40B4-BE49-F238E27FC236}">
+                <a16:creationId xmlns:a16="http://schemas.microsoft.com/office/drawing/2014/main" id="{71745C6C-E986-6E03-B4C7-05CAEBF26B4A}"/>
+              </a:ext>
+            </a:extLst>
+          </p:cNvPr>
+          <p:cNvSpPr txBox="1"/>
+          <p:nvPr/>
+        </p:nvSpPr>
+        <p:spPr>
+          <a:xfrm>
+            <a:off x="978196" y="3370796"/>
+            <a:ext cx="714153" cy="461665"/>
+          </a:xfrm>
+          <a:prstGeom prst="rect">
+            <a:avLst/>
+          </a:prstGeom>
+          <a:solidFill>
+            <a:schemeClr val="bg1"/>
+          </a:solidFill>
+        </p:spPr>
+        <p:txBody>
+          <a:bodyPr wrap="square" rtlCol="0">
+            <a:spAutoFit/>
+          </a:bodyPr>
+          <a:lstStyle/>
+          <a:p>
+            <a:pPr algn="ctr"/>
+            <a:r>
+              <a:rPr lang="en-US" sz="2400" dirty="0"/>
+              <a:t>1-</a:t>
+            </a:r>
+            <a:r>
+              <a:rPr lang="en-US" sz="2400" i="1" dirty="0"/>
+              <a:t>m</a:t>
+            </a:r>
+          </a:p>
+        </p:txBody>
+      </p:sp>
+      <p:sp>
+        <p:nvSpPr>
+          <p:cNvPr id="14" name="TextBox 13">
+            <a:extLst>
+              <a:ext uri="{FF2B5EF4-FFF2-40B4-BE49-F238E27FC236}">
+                <a16:creationId xmlns:a16="http://schemas.microsoft.com/office/drawing/2014/main" id="{15F45A4E-9B7C-3D43-CAE5-7AE4B1A77C9A}"/>
+              </a:ext>
+            </a:extLst>
+          </p:cNvPr>
+          <p:cNvSpPr txBox="1"/>
+          <p:nvPr/>
+        </p:nvSpPr>
+        <p:spPr>
+          <a:xfrm>
+            <a:off x="2353782" y="3244334"/>
+            <a:ext cx="393405" cy="461665"/>
+          </a:xfrm>
+          <a:prstGeom prst="rect">
+            <a:avLst/>
+          </a:prstGeom>
+          <a:solidFill>
+            <a:schemeClr val="bg1"/>
+          </a:solidFill>
+        </p:spPr>
+        <p:txBody>
+          <a:bodyPr wrap="square" rtlCol="0">
+            <a:spAutoFit/>
+          </a:bodyPr>
+          <a:lstStyle/>
+          <a:p>
+            <a:pPr algn="ctr"/>
+            <a:r>
+              <a:rPr lang="en-US" sz="2400" i="1" dirty="0"/>
+              <a:t>g</a:t>
+            </a:r>
+          </a:p>
+        </p:txBody>
+      </p:sp>
+      <p:sp>
+        <p:nvSpPr>
+          <p:cNvPr id="15" name="TextBox 14">
+            <a:extLst>
+              <a:ext uri="{FF2B5EF4-FFF2-40B4-BE49-F238E27FC236}">
+                <a16:creationId xmlns:a16="http://schemas.microsoft.com/office/drawing/2014/main" id="{DA316A61-9CFD-4B07-5428-2E14E2337A12}"/>
+              </a:ext>
+            </a:extLst>
+          </p:cNvPr>
+          <p:cNvSpPr txBox="1"/>
+          <p:nvPr/>
+        </p:nvSpPr>
+        <p:spPr>
+          <a:xfrm>
+            <a:off x="2056070" y="3946703"/>
+            <a:ext cx="691117" cy="461665"/>
+          </a:xfrm>
+          <a:prstGeom prst="rect">
+            <a:avLst/>
+          </a:prstGeom>
+          <a:solidFill>
+            <a:schemeClr val="bg1"/>
+          </a:solidFill>
+        </p:spPr>
+        <p:txBody>
+          <a:bodyPr wrap="square" rtlCol="0">
+            <a:spAutoFit/>
+          </a:bodyPr>
+          <a:lstStyle/>
+          <a:p>
+            <a:pPr algn="ctr"/>
+            <a:r>
+              <a:rPr lang="en-US" sz="2400" dirty="0"/>
+              <a:t>1-</a:t>
+            </a:r>
+            <a:r>
+              <a:rPr lang="en-US" sz="2400" i="1" dirty="0"/>
+              <a:t>g</a:t>
+            </a:r>
+          </a:p>
+        </p:txBody>
+      </p:sp>
+      <p:sp>
+        <p:nvSpPr>
+          <p:cNvPr id="16" name="TextBox 15">
+            <a:extLst>
+              <a:ext uri="{FF2B5EF4-FFF2-40B4-BE49-F238E27FC236}">
+                <a16:creationId xmlns:a16="http://schemas.microsoft.com/office/drawing/2014/main" id="{5A95C858-CE0D-1917-EEFB-371B390FC7CE}"/>
+              </a:ext>
+            </a:extLst>
+          </p:cNvPr>
+          <p:cNvSpPr txBox="1"/>
+          <p:nvPr/>
+        </p:nvSpPr>
+        <p:spPr>
+          <a:xfrm>
+            <a:off x="5465132" y="2019532"/>
+            <a:ext cx="393405" cy="461665"/>
+          </a:xfrm>
+          <a:prstGeom prst="rect">
+            <a:avLst/>
+          </a:prstGeom>
+          <a:solidFill>
+            <a:schemeClr val="bg1"/>
+          </a:solidFill>
+        </p:spPr>
+        <p:txBody>
+          <a:bodyPr wrap="square" rtlCol="0">
+            <a:spAutoFit/>
+          </a:bodyPr>
+          <a:lstStyle/>
+          <a:p>
+            <a:pPr algn="ctr"/>
+            <a:r>
+              <a:rPr lang="en-US" sz="2400" i="1" dirty="0"/>
+              <a:t>m</a:t>
+            </a:r>
+          </a:p>
+        </p:txBody>
+      </p:sp>
+      <p:sp>
+        <p:nvSpPr>
+          <p:cNvPr id="17" name="TextBox 16">
+            <a:extLst>
+              <a:ext uri="{FF2B5EF4-FFF2-40B4-BE49-F238E27FC236}">
+                <a16:creationId xmlns:a16="http://schemas.microsoft.com/office/drawing/2014/main" id="{2EF489BD-7A72-5C81-45E1-A794BC597EB6}"/>
+              </a:ext>
+            </a:extLst>
+          </p:cNvPr>
+          <p:cNvSpPr txBox="1"/>
+          <p:nvPr/>
+        </p:nvSpPr>
+        <p:spPr>
+          <a:xfrm>
+            <a:off x="5165650" y="3370796"/>
+            <a:ext cx="714153" cy="461665"/>
+          </a:xfrm>
+          <a:prstGeom prst="rect">
+            <a:avLst/>
+          </a:prstGeom>
+          <a:solidFill>
+            <a:schemeClr val="bg1"/>
+          </a:solidFill>
+        </p:spPr>
+        <p:txBody>
+          <a:bodyPr wrap="square" rtlCol="0">
+            <a:spAutoFit/>
+          </a:bodyPr>
+          <a:lstStyle/>
+          <a:p>
+            <a:pPr algn="ctr"/>
+            <a:r>
+              <a:rPr lang="en-US" sz="2400" dirty="0"/>
+              <a:t>1-</a:t>
+            </a:r>
+            <a:r>
+              <a:rPr lang="en-US" sz="2400" i="1" dirty="0"/>
+              <a:t>m</a:t>
+            </a:r>
+          </a:p>
+        </p:txBody>
+      </p:sp>
+      <p:sp>
+        <p:nvSpPr>
+          <p:cNvPr id="18" name="TextBox 17">
+            <a:extLst>
+              <a:ext uri="{FF2B5EF4-FFF2-40B4-BE49-F238E27FC236}">
+                <a16:creationId xmlns:a16="http://schemas.microsoft.com/office/drawing/2014/main" id="{4250F291-6E87-0490-1482-BB0ED3579292}"/>
+              </a:ext>
+            </a:extLst>
+          </p:cNvPr>
+          <p:cNvSpPr txBox="1"/>
+          <p:nvPr/>
+        </p:nvSpPr>
+        <p:spPr>
+          <a:xfrm>
+            <a:off x="6541236" y="3244334"/>
+            <a:ext cx="393405" cy="461665"/>
+          </a:xfrm>
+          <a:prstGeom prst="rect">
+            <a:avLst/>
+          </a:prstGeom>
+          <a:solidFill>
+            <a:schemeClr val="bg1"/>
+          </a:solidFill>
+        </p:spPr>
+        <p:txBody>
+          <a:bodyPr wrap="square" rtlCol="0">
+            <a:spAutoFit/>
+          </a:bodyPr>
+          <a:lstStyle/>
+          <a:p>
+            <a:pPr algn="ctr"/>
+            <a:r>
+              <a:rPr lang="en-US" sz="2400" i="1" dirty="0"/>
+              <a:t>g</a:t>
+            </a:r>
+          </a:p>
+        </p:txBody>
+      </p:sp>
+      <p:sp>
+        <p:nvSpPr>
+          <p:cNvPr id="19" name="TextBox 18">
+            <a:extLst>
+              <a:ext uri="{FF2B5EF4-FFF2-40B4-BE49-F238E27FC236}">
+                <a16:creationId xmlns:a16="http://schemas.microsoft.com/office/drawing/2014/main" id="{CC067376-26FA-D535-5018-D7219C9FFEEF}"/>
+              </a:ext>
+            </a:extLst>
+          </p:cNvPr>
+          <p:cNvSpPr txBox="1"/>
+          <p:nvPr/>
+        </p:nvSpPr>
+        <p:spPr>
+          <a:xfrm>
+            <a:off x="6243524" y="3946703"/>
+            <a:ext cx="691117" cy="461665"/>
+          </a:xfrm>
+          <a:prstGeom prst="rect">
+            <a:avLst/>
+          </a:prstGeom>
+          <a:solidFill>
+            <a:schemeClr val="bg1"/>
+          </a:solidFill>
+        </p:spPr>
+        <p:txBody>
+          <a:bodyPr wrap="square" rtlCol="0">
+            <a:spAutoFit/>
+          </a:bodyPr>
+          <a:lstStyle/>
+          <a:p>
+            <a:pPr algn="ctr"/>
+            <a:r>
+              <a:rPr lang="en-US" sz="2400" dirty="0"/>
+              <a:t>1-</a:t>
+            </a:r>
+            <a:r>
+              <a:rPr lang="en-US" sz="2400" i="1" dirty="0"/>
+              <a:t>g</a:t>
             </a:r>
           </a:p>
         </p:txBody>
@@ -4888,7 +5192,7 @@
         <p:cNvPr id="1" name="">
           <a:extLst>
             <a:ext uri="{FF2B5EF4-FFF2-40B4-BE49-F238E27FC236}">
-              <a16:creationId xmlns:a16="http://schemas.microsoft.com/office/drawing/2014/main" id="{ACCA7967-E7A0-2D07-277B-EB8F98BF45C8}"/>
+              <a16:creationId xmlns:a16="http://schemas.microsoft.com/office/drawing/2014/main" id="{65F314E0-7C0C-302D-0321-388E6A74C82E}"/>
             </a:ext>
           </a:extLst>
         </p:cNvPr>
@@ -4908,7 +5212,7 @@
           <p:cNvPr id="2" name="Title 1">
             <a:extLst>
               <a:ext uri="{FF2B5EF4-FFF2-40B4-BE49-F238E27FC236}">
-                <a16:creationId xmlns:a16="http://schemas.microsoft.com/office/drawing/2014/main" id="{0FFD9A34-7263-0B9C-BA18-D16413ABC01D}"/>
+                <a16:creationId xmlns:a16="http://schemas.microsoft.com/office/drawing/2014/main" id="{11B64BA0-E11F-30A0-12D4-BD214C7B6F8E}"/>
               </a:ext>
             </a:extLst>
           </p:cNvPr>
@@ -4921,8 +5225,8 @@
         </p:nvSpPr>
         <p:spPr>
           <a:xfrm>
-            <a:off x="838199" y="-113348"/>
-            <a:ext cx="10985205" cy="1325563"/>
+            <a:off x="838200" y="-262210"/>
+            <a:ext cx="10932042" cy="1325563"/>
           </a:xfrm>
         </p:spPr>
         <p:txBody>
@@ -4949,7 +5253,7 @@
           <p:cNvPr id="5" name="Content Placeholder 4" descr="A diagram of a hexagon&#10;&#10;AI-generated content may be incorrect.">
             <a:extLst>
               <a:ext uri="{FF2B5EF4-FFF2-40B4-BE49-F238E27FC236}">
-                <a16:creationId xmlns:a16="http://schemas.microsoft.com/office/drawing/2014/main" id="{5CC004D6-C498-FF4D-CCDC-38B25E1C67FD}"/>
+                <a16:creationId xmlns:a16="http://schemas.microsoft.com/office/drawing/2014/main" id="{92DCAE5A-86F0-934B-1528-357407E5AF5B}"/>
               </a:ext>
             </a:extLst>
           </p:cNvPr>
@@ -4968,7 +5272,7 @@
         </p:blipFill>
         <p:spPr>
           <a:xfrm>
-            <a:off x="1084522" y="1212215"/>
+            <a:off x="1075662" y="1211861"/>
             <a:ext cx="9812079" cy="3082473"/>
           </a:xfrm>
         </p:spPr>
@@ -4978,7 +5282,7 @@
           <p:cNvPr id="6" name="TextBox 5">
             <a:extLst>
               <a:ext uri="{FF2B5EF4-FFF2-40B4-BE49-F238E27FC236}">
-                <a16:creationId xmlns:a16="http://schemas.microsoft.com/office/drawing/2014/main" id="{8022F2CA-5981-B8CE-BB2D-5D55489240A6}"/>
+                <a16:creationId xmlns:a16="http://schemas.microsoft.com/office/drawing/2014/main" id="{FF20B072-C2E4-AEA1-1AA4-1890631C6A44}"/>
               </a:ext>
             </a:extLst>
           </p:cNvPr>
@@ -4987,7 +5291,7 @@
         </p:nvSpPr>
         <p:spPr>
           <a:xfrm>
-            <a:off x="1137684" y="786576"/>
+            <a:off x="1137684" y="712146"/>
             <a:ext cx="3402419" cy="584775"/>
           </a:xfrm>
           <a:prstGeom prst="rect">
@@ -5014,7 +5318,7 @@
           <p:cNvPr id="7" name="TextBox 6">
             <a:extLst>
               <a:ext uri="{FF2B5EF4-FFF2-40B4-BE49-F238E27FC236}">
-                <a16:creationId xmlns:a16="http://schemas.microsoft.com/office/drawing/2014/main" id="{E816E08C-2950-C17F-02A6-1F6AF4905C76}"/>
+                <a16:creationId xmlns:a16="http://schemas.microsoft.com/office/drawing/2014/main" id="{BE4C3934-7AD5-8166-0698-2FAD533FD419}"/>
               </a:ext>
             </a:extLst>
           </p:cNvPr>
@@ -5023,7 +5327,7 @@
         </p:nvSpPr>
         <p:spPr>
           <a:xfrm>
-            <a:off x="6861545" y="786576"/>
+            <a:off x="6861545" y="712146"/>
             <a:ext cx="3402419" cy="584775"/>
           </a:xfrm>
           <a:prstGeom prst="rect">
@@ -5050,7 +5354,7 @@
           <p:cNvPr id="8" name="TextBox 7">
             <a:extLst>
               <a:ext uri="{FF2B5EF4-FFF2-40B4-BE49-F238E27FC236}">
-                <a16:creationId xmlns:a16="http://schemas.microsoft.com/office/drawing/2014/main" id="{F7C85E0D-D1B6-D085-C3C7-D18C43D32630}"/>
+                <a16:creationId xmlns:a16="http://schemas.microsoft.com/office/drawing/2014/main" id="{C99B57C0-0A31-8067-4506-A063D9561EDE}"/>
               </a:ext>
             </a:extLst>
           </p:cNvPr>
@@ -5059,7 +5363,7 @@
         </p:nvSpPr>
         <p:spPr>
           <a:xfrm>
-            <a:off x="838200" y="5452028"/>
+            <a:off x="838200" y="5515844"/>
             <a:ext cx="10829260" cy="1323439"/>
           </a:xfrm>
           <a:prstGeom prst="rect">
@@ -5075,11 +5379,11 @@
           <a:p>
             <a:r>
               <a:rPr lang="en-US" sz="2000" i="1" dirty="0"/>
-              <a:t>D</a:t>
+              <a:t>m</a:t>
             </a:r>
             <a:r>
               <a:rPr lang="en-US" sz="2000" dirty="0"/>
-              <a:t> (detection, probability that study </a:t>
+              <a:t> (probability that study </a:t>
             </a:r>
             <a:r>
               <a:rPr lang="en-US" sz="2000" dirty="0" err="1"/>
@@ -5119,29 +5423,13 @@
             </a:r>
             <a:r>
               <a:rPr lang="en-US" sz="2000" dirty="0"/>
-              <a:t> = study set size. [</a:t>
-            </a:r>
+              <a:t> = study set size. </a:t>
+            </a:r>
+          </a:p>
+          <a:p>
             <a:r>
               <a:rPr lang="en-US" sz="2000" i="1" dirty="0"/>
-              <a:t>D</a:t>
-            </a:r>
-            <a:r>
-              <a:rPr lang="en-US" sz="2000" dirty="0"/>
-              <a:t> is called </a:t>
-            </a:r>
-            <a:r>
-              <a:rPr lang="en-US" sz="2000" i="1" dirty="0"/>
-              <a:t>m</a:t>
-            </a:r>
-            <a:r>
-              <a:rPr lang="en-US" sz="2000" dirty="0"/>
-              <a:t> in code]</a:t>
-            </a:r>
-          </a:p>
-          <a:p>
-            <a:r>
-              <a:rPr lang="en-US" sz="2000" i="1" dirty="0"/>
-              <a:t>G</a:t>
+              <a:t>g</a:t>
             </a:r>
             <a:r>
               <a:rPr lang="en-US" sz="2000" dirty="0"/>
@@ -5160,12 +5448,332 @@
           </a:p>
         </p:txBody>
       </p:sp>
+      <p:sp>
+        <p:nvSpPr>
+          <p:cNvPr id="4" name="TextBox 3">
+            <a:extLst>
+              <a:ext uri="{FF2B5EF4-FFF2-40B4-BE49-F238E27FC236}">
+                <a16:creationId xmlns:a16="http://schemas.microsoft.com/office/drawing/2014/main" id="{CA8E1509-69D6-5440-20E7-6B0474CA62AC}"/>
+              </a:ext>
+            </a:extLst>
+          </p:cNvPr>
+          <p:cNvSpPr txBox="1"/>
+          <p:nvPr/>
+        </p:nvSpPr>
+        <p:spPr>
+          <a:xfrm>
+            <a:off x="1320210" y="1721816"/>
+            <a:ext cx="393405" cy="461665"/>
+          </a:xfrm>
+          <a:prstGeom prst="rect">
+            <a:avLst/>
+          </a:prstGeom>
+          <a:solidFill>
+            <a:schemeClr val="bg1"/>
+          </a:solidFill>
+        </p:spPr>
+        <p:txBody>
+          <a:bodyPr wrap="square" rtlCol="0">
+            <a:spAutoFit/>
+          </a:bodyPr>
+          <a:lstStyle/>
+          <a:p>
+            <a:pPr algn="ctr"/>
+            <a:r>
+              <a:rPr lang="en-US" sz="2400" i="1" dirty="0"/>
+              <a:t>m</a:t>
+            </a:r>
+          </a:p>
+        </p:txBody>
+      </p:sp>
+      <p:sp>
+        <p:nvSpPr>
+          <p:cNvPr id="9" name="TextBox 8">
+            <a:extLst>
+              <a:ext uri="{FF2B5EF4-FFF2-40B4-BE49-F238E27FC236}">
+                <a16:creationId xmlns:a16="http://schemas.microsoft.com/office/drawing/2014/main" id="{D2183B18-3F07-317A-304B-DDFAB50AA224}"/>
+              </a:ext>
+            </a:extLst>
+          </p:cNvPr>
+          <p:cNvSpPr txBox="1"/>
+          <p:nvPr/>
+        </p:nvSpPr>
+        <p:spPr>
+          <a:xfrm>
+            <a:off x="1020728" y="3073080"/>
+            <a:ext cx="714153" cy="461665"/>
+          </a:xfrm>
+          <a:prstGeom prst="rect">
+            <a:avLst/>
+          </a:prstGeom>
+          <a:solidFill>
+            <a:schemeClr val="bg1"/>
+          </a:solidFill>
+        </p:spPr>
+        <p:txBody>
+          <a:bodyPr wrap="square" rtlCol="0">
+            <a:spAutoFit/>
+          </a:bodyPr>
+          <a:lstStyle/>
+          <a:p>
+            <a:pPr algn="ctr"/>
+            <a:r>
+              <a:rPr lang="en-US" sz="2400" dirty="0"/>
+              <a:t>1-</a:t>
+            </a:r>
+            <a:r>
+              <a:rPr lang="en-US" sz="2400" i="1" dirty="0"/>
+              <a:t>m</a:t>
+            </a:r>
+          </a:p>
+        </p:txBody>
+      </p:sp>
+      <p:sp>
+        <p:nvSpPr>
+          <p:cNvPr id="14" name="TextBox 13">
+            <a:extLst>
+              <a:ext uri="{FF2B5EF4-FFF2-40B4-BE49-F238E27FC236}">
+                <a16:creationId xmlns:a16="http://schemas.microsoft.com/office/drawing/2014/main" id="{9F20DD21-9481-BC7D-81B4-E670204FE0C7}"/>
+              </a:ext>
+            </a:extLst>
+          </p:cNvPr>
+          <p:cNvSpPr txBox="1"/>
+          <p:nvPr/>
+        </p:nvSpPr>
+        <p:spPr>
+          <a:xfrm>
+            <a:off x="2396314" y="2946618"/>
+            <a:ext cx="393405" cy="461665"/>
+          </a:xfrm>
+          <a:prstGeom prst="rect">
+            <a:avLst/>
+          </a:prstGeom>
+          <a:solidFill>
+            <a:schemeClr val="bg1"/>
+          </a:solidFill>
+        </p:spPr>
+        <p:txBody>
+          <a:bodyPr wrap="square" rtlCol="0">
+            <a:spAutoFit/>
+          </a:bodyPr>
+          <a:lstStyle/>
+          <a:p>
+            <a:pPr algn="ctr"/>
+            <a:r>
+              <a:rPr lang="en-US" sz="2400" i="1" dirty="0"/>
+              <a:t>g</a:t>
+            </a:r>
+          </a:p>
+        </p:txBody>
+      </p:sp>
+      <p:sp>
+        <p:nvSpPr>
+          <p:cNvPr id="15" name="TextBox 14">
+            <a:extLst>
+              <a:ext uri="{FF2B5EF4-FFF2-40B4-BE49-F238E27FC236}">
+                <a16:creationId xmlns:a16="http://schemas.microsoft.com/office/drawing/2014/main" id="{FEC9209D-21A2-CE83-33A2-234C2F852B72}"/>
+              </a:ext>
+            </a:extLst>
+          </p:cNvPr>
+          <p:cNvSpPr txBox="1"/>
+          <p:nvPr/>
+        </p:nvSpPr>
+        <p:spPr>
+          <a:xfrm>
+            <a:off x="2098602" y="3648987"/>
+            <a:ext cx="691117" cy="461665"/>
+          </a:xfrm>
+          <a:prstGeom prst="rect">
+            <a:avLst/>
+          </a:prstGeom>
+          <a:solidFill>
+            <a:schemeClr val="bg1"/>
+          </a:solidFill>
+        </p:spPr>
+        <p:txBody>
+          <a:bodyPr wrap="square" rtlCol="0">
+            <a:spAutoFit/>
+          </a:bodyPr>
+          <a:lstStyle/>
+          <a:p>
+            <a:pPr algn="ctr"/>
+            <a:r>
+              <a:rPr lang="en-US" sz="2400" dirty="0"/>
+              <a:t>1-</a:t>
+            </a:r>
+            <a:r>
+              <a:rPr lang="en-US" sz="2400" i="1" dirty="0"/>
+              <a:t>g</a:t>
+            </a:r>
+          </a:p>
+        </p:txBody>
+      </p:sp>
+      <p:sp>
+        <p:nvSpPr>
+          <p:cNvPr id="16" name="TextBox 15">
+            <a:extLst>
+              <a:ext uri="{FF2B5EF4-FFF2-40B4-BE49-F238E27FC236}">
+                <a16:creationId xmlns:a16="http://schemas.microsoft.com/office/drawing/2014/main" id="{2909F49F-63BD-3FE2-35AF-0B5872F6D5B6}"/>
+              </a:ext>
+            </a:extLst>
+          </p:cNvPr>
+          <p:cNvSpPr txBox="1"/>
+          <p:nvPr/>
+        </p:nvSpPr>
+        <p:spPr>
+          <a:xfrm>
+            <a:off x="5507664" y="1721816"/>
+            <a:ext cx="393405" cy="461665"/>
+          </a:xfrm>
+          <a:prstGeom prst="rect">
+            <a:avLst/>
+          </a:prstGeom>
+          <a:solidFill>
+            <a:schemeClr val="bg1"/>
+          </a:solidFill>
+        </p:spPr>
+        <p:txBody>
+          <a:bodyPr wrap="square" rtlCol="0">
+            <a:spAutoFit/>
+          </a:bodyPr>
+          <a:lstStyle/>
+          <a:p>
+            <a:pPr algn="ctr"/>
+            <a:r>
+              <a:rPr lang="en-US" sz="2400" i="1" dirty="0"/>
+              <a:t>m</a:t>
+            </a:r>
+          </a:p>
+        </p:txBody>
+      </p:sp>
+      <p:sp>
+        <p:nvSpPr>
+          <p:cNvPr id="17" name="TextBox 16">
+            <a:extLst>
+              <a:ext uri="{FF2B5EF4-FFF2-40B4-BE49-F238E27FC236}">
+                <a16:creationId xmlns:a16="http://schemas.microsoft.com/office/drawing/2014/main" id="{6D45ADEA-A809-0C40-BCB4-701A8F9D3786}"/>
+              </a:ext>
+            </a:extLst>
+          </p:cNvPr>
+          <p:cNvSpPr txBox="1"/>
+          <p:nvPr/>
+        </p:nvSpPr>
+        <p:spPr>
+          <a:xfrm>
+            <a:off x="5208182" y="3073080"/>
+            <a:ext cx="714153" cy="461665"/>
+          </a:xfrm>
+          <a:prstGeom prst="rect">
+            <a:avLst/>
+          </a:prstGeom>
+          <a:solidFill>
+            <a:schemeClr val="bg1"/>
+          </a:solidFill>
+        </p:spPr>
+        <p:txBody>
+          <a:bodyPr wrap="square" rtlCol="0">
+            <a:spAutoFit/>
+          </a:bodyPr>
+          <a:lstStyle/>
+          <a:p>
+            <a:pPr algn="ctr"/>
+            <a:r>
+              <a:rPr lang="en-US" sz="2400" dirty="0"/>
+              <a:t>1-</a:t>
+            </a:r>
+            <a:r>
+              <a:rPr lang="en-US" sz="2400" i="1" dirty="0"/>
+              <a:t>m</a:t>
+            </a:r>
+          </a:p>
+        </p:txBody>
+      </p:sp>
+      <p:sp>
+        <p:nvSpPr>
+          <p:cNvPr id="18" name="TextBox 17">
+            <a:extLst>
+              <a:ext uri="{FF2B5EF4-FFF2-40B4-BE49-F238E27FC236}">
+                <a16:creationId xmlns:a16="http://schemas.microsoft.com/office/drawing/2014/main" id="{99E71767-3709-9320-FDCA-CAEB73BE9C80}"/>
+              </a:ext>
+            </a:extLst>
+          </p:cNvPr>
+          <p:cNvSpPr txBox="1"/>
+          <p:nvPr/>
+        </p:nvSpPr>
+        <p:spPr>
+          <a:xfrm>
+            <a:off x="6583768" y="2946618"/>
+            <a:ext cx="393405" cy="461665"/>
+          </a:xfrm>
+          <a:prstGeom prst="rect">
+            <a:avLst/>
+          </a:prstGeom>
+          <a:solidFill>
+            <a:schemeClr val="bg1"/>
+          </a:solidFill>
+        </p:spPr>
+        <p:txBody>
+          <a:bodyPr wrap="square" rtlCol="0">
+            <a:spAutoFit/>
+          </a:bodyPr>
+          <a:lstStyle/>
+          <a:p>
+            <a:pPr algn="ctr"/>
+            <a:r>
+              <a:rPr lang="en-US" sz="2400" i="1" dirty="0"/>
+              <a:t>g</a:t>
+            </a:r>
+          </a:p>
+        </p:txBody>
+      </p:sp>
+      <p:sp>
+        <p:nvSpPr>
+          <p:cNvPr id="19" name="TextBox 18">
+            <a:extLst>
+              <a:ext uri="{FF2B5EF4-FFF2-40B4-BE49-F238E27FC236}">
+                <a16:creationId xmlns:a16="http://schemas.microsoft.com/office/drawing/2014/main" id="{8FF35097-0660-5305-568F-B8F9D56338B3}"/>
+              </a:ext>
+            </a:extLst>
+          </p:cNvPr>
+          <p:cNvSpPr txBox="1"/>
+          <p:nvPr/>
+        </p:nvSpPr>
+        <p:spPr>
+          <a:xfrm>
+            <a:off x="6286056" y="3648987"/>
+            <a:ext cx="691117" cy="461665"/>
+          </a:xfrm>
+          <a:prstGeom prst="rect">
+            <a:avLst/>
+          </a:prstGeom>
+          <a:solidFill>
+            <a:schemeClr val="bg1"/>
+          </a:solidFill>
+        </p:spPr>
+        <p:txBody>
+          <a:bodyPr wrap="square" rtlCol="0">
+            <a:spAutoFit/>
+          </a:bodyPr>
+          <a:lstStyle/>
+          <a:p>
+            <a:pPr algn="ctr"/>
+            <a:r>
+              <a:rPr lang="en-US" sz="2400" dirty="0"/>
+              <a:t>1-</a:t>
+            </a:r>
+            <a:r>
+              <a:rPr lang="en-US" sz="2400" i="1" dirty="0"/>
+              <a:t>g</a:t>
+            </a:r>
+          </a:p>
+        </p:txBody>
+      </p:sp>
       <p:cxnSp>
         <p:nvCxnSpPr>
-          <p:cNvPr id="9" name="Straight Connector 8">
-            <a:extLst>
-              <a:ext uri="{FF2B5EF4-FFF2-40B4-BE49-F238E27FC236}">
-                <a16:creationId xmlns:a16="http://schemas.microsoft.com/office/drawing/2014/main" id="{F7EDAE10-BF4F-6739-34E8-5670D0BF1DE5}"/>
+          <p:cNvPr id="10" name="Straight Connector 9">
+            <a:extLst>
+              <a:ext uri="{FF2B5EF4-FFF2-40B4-BE49-F238E27FC236}">
+                <a16:creationId xmlns:a16="http://schemas.microsoft.com/office/drawing/2014/main" id="{AF824D50-9005-78AF-C415-7482219D602E}"/>
               </a:ext>
             </a:extLst>
           </p:cNvPr>
@@ -5206,7 +5814,7 @@
           <p:cNvPr id="11" name="Straight Connector 10">
             <a:extLst>
               <a:ext uri="{FF2B5EF4-FFF2-40B4-BE49-F238E27FC236}">
-                <a16:creationId xmlns:a16="http://schemas.microsoft.com/office/drawing/2014/main" id="{502D44AE-84C4-ACC6-60C7-047FD38D18A2}"/>
+                <a16:creationId xmlns:a16="http://schemas.microsoft.com/office/drawing/2014/main" id="{8C82B59E-6B39-AECA-46FB-6E6D4593BF06}"/>
               </a:ext>
             </a:extLst>
           </p:cNvPr>
@@ -5217,6 +5825,49 @@
           <a:xfrm>
             <a:off x="648586" y="3625702"/>
             <a:ext cx="1063256" cy="1041991"/>
+          </a:xfrm>
+          <a:prstGeom prst="line">
+            <a:avLst/>
+          </a:prstGeom>
+          <a:ln>
+            <a:solidFill>
+              <a:schemeClr val="tx1"/>
+            </a:solidFill>
+          </a:ln>
+        </p:spPr>
+        <p:style>
+          <a:lnRef idx="2">
+            <a:schemeClr val="accent1"/>
+          </a:lnRef>
+          <a:fillRef idx="0">
+            <a:schemeClr val="accent1"/>
+          </a:fillRef>
+          <a:effectRef idx="1">
+            <a:schemeClr val="accent1"/>
+          </a:effectRef>
+          <a:fontRef idx="minor">
+            <a:schemeClr val="tx1"/>
+          </a:fontRef>
+        </p:style>
+      </p:cxnSp>
+      <p:cxnSp>
+        <p:nvCxnSpPr>
+          <p:cNvPr id="12" name="Straight Connector 11">
+            <a:extLst>
+              <a:ext uri="{FF2B5EF4-FFF2-40B4-BE49-F238E27FC236}">
+                <a16:creationId xmlns:a16="http://schemas.microsoft.com/office/drawing/2014/main" id="{940509D2-0327-DE62-D0A3-C2A68C8E48EF}"/>
+              </a:ext>
+            </a:extLst>
+          </p:cNvPr>
+          <p:cNvCxnSpPr>
+            <a:cxnSpLocks/>
+          </p:cNvCxnSpPr>
+          <p:nvPr/>
+        </p:nvCxnSpPr>
+        <p:spPr>
+          <a:xfrm flipV="1">
+            <a:off x="1711842" y="4438394"/>
+            <a:ext cx="1977656" cy="229299"/>
           </a:xfrm>
           <a:prstGeom prst="line">
             <a:avLst/>
@@ -5247,7 +5898,7 @@
           <p:cNvPr id="13" name="Straight Connector 12">
             <a:extLst>
               <a:ext uri="{FF2B5EF4-FFF2-40B4-BE49-F238E27FC236}">
-                <a16:creationId xmlns:a16="http://schemas.microsoft.com/office/drawing/2014/main" id="{B571896C-33E1-DE95-DEC4-62EEA3E1BB4C}"/>
+                <a16:creationId xmlns:a16="http://schemas.microsoft.com/office/drawing/2014/main" id="{50BB591F-9B38-69EB-02C3-BDD749FC6A98}"/>
               </a:ext>
             </a:extLst>
           </p:cNvPr>
@@ -5257,9 +5908,9 @@
           <p:nvPr/>
         </p:nvCxnSpPr>
         <p:spPr>
-          <a:xfrm flipV="1">
-            <a:off x="1711842" y="4438394"/>
-            <a:ext cx="1977656" cy="229299"/>
+          <a:xfrm>
+            <a:off x="1711842" y="4667693"/>
+            <a:ext cx="1977656" cy="308344"/>
           </a:xfrm>
           <a:prstGeom prst="line">
             <a:avLst/>
@@ -5285,55 +5936,12 @@
           </a:fontRef>
         </p:style>
       </p:cxnSp>
-      <p:cxnSp>
-        <p:nvCxnSpPr>
-          <p:cNvPr id="17" name="Straight Connector 16">
-            <a:extLst>
-              <a:ext uri="{FF2B5EF4-FFF2-40B4-BE49-F238E27FC236}">
-                <a16:creationId xmlns:a16="http://schemas.microsoft.com/office/drawing/2014/main" id="{72423707-4041-B35D-F38B-5F84999BF9CD}"/>
-              </a:ext>
-            </a:extLst>
-          </p:cNvPr>
-          <p:cNvCxnSpPr>
-            <a:cxnSpLocks/>
-          </p:cNvCxnSpPr>
-          <p:nvPr/>
-        </p:nvCxnSpPr>
-        <p:spPr>
-          <a:xfrm>
-            <a:off x="1711842" y="4667693"/>
-            <a:ext cx="1977656" cy="308344"/>
-          </a:xfrm>
-          <a:prstGeom prst="line">
-            <a:avLst/>
-          </a:prstGeom>
-          <a:ln>
-            <a:solidFill>
-              <a:schemeClr val="tx1"/>
-            </a:solidFill>
-          </a:ln>
-        </p:spPr>
-        <p:style>
-          <a:lnRef idx="2">
-            <a:schemeClr val="accent1"/>
-          </a:lnRef>
-          <a:fillRef idx="0">
-            <a:schemeClr val="accent1"/>
-          </a:fillRef>
-          <a:effectRef idx="1">
-            <a:schemeClr val="accent1"/>
-          </a:effectRef>
-          <a:fontRef idx="minor">
-            <a:schemeClr val="tx1"/>
-          </a:fontRef>
-        </p:style>
-      </p:cxnSp>
       <p:sp>
         <p:nvSpPr>
           <p:cNvPr id="20" name="TextBox 19">
             <a:extLst>
               <a:ext uri="{FF2B5EF4-FFF2-40B4-BE49-F238E27FC236}">
-                <a16:creationId xmlns:a16="http://schemas.microsoft.com/office/drawing/2014/main" id="{4FDBC241-7F38-4468-B3F4-9D5F23573024}"/>
+                <a16:creationId xmlns:a16="http://schemas.microsoft.com/office/drawing/2014/main" id="{B739C204-553C-B769-98AB-6595CE0CE521}"/>
               </a:ext>
             </a:extLst>
           </p:cNvPr>
@@ -5368,7 +5976,7 @@
           <p:cNvPr id="21" name="TextBox 20">
             <a:extLst>
               <a:ext uri="{FF2B5EF4-FFF2-40B4-BE49-F238E27FC236}">
-                <a16:creationId xmlns:a16="http://schemas.microsoft.com/office/drawing/2014/main" id="{28EBCA64-94B2-DE20-F6A3-C7F2801BD9BE}"/>
+                <a16:creationId xmlns:a16="http://schemas.microsoft.com/office/drawing/2014/main" id="{56EE6389-9BEE-228D-7022-0EBC56280A21}"/>
               </a:ext>
             </a:extLst>
           </p:cNvPr>
@@ -5403,7 +6011,7 @@
           <p:cNvPr id="22" name="TextBox 21">
             <a:extLst>
               <a:ext uri="{FF2B5EF4-FFF2-40B4-BE49-F238E27FC236}">
-                <a16:creationId xmlns:a16="http://schemas.microsoft.com/office/drawing/2014/main" id="{F3D970DD-3ABD-F315-5686-48467A7E9F53}"/>
+                <a16:creationId xmlns:a16="http://schemas.microsoft.com/office/drawing/2014/main" id="{A73D687D-19D5-6D11-4750-109493052517}"/>
               </a:ext>
             </a:extLst>
           </p:cNvPr>
@@ -5427,8 +6035,8 @@
           <a:lstStyle/>
           <a:p>
             <a:r>
-              <a:rPr lang="en-US" dirty="0"/>
-              <a:t>G</a:t>
+              <a:rPr lang="en-US" i="1" dirty="0"/>
+              <a:t>g</a:t>
             </a:r>
           </a:p>
         </p:txBody>
@@ -5438,7 +6046,7 @@
           <p:cNvPr id="23" name="TextBox 22">
             <a:extLst>
               <a:ext uri="{FF2B5EF4-FFF2-40B4-BE49-F238E27FC236}">
-                <a16:creationId xmlns:a16="http://schemas.microsoft.com/office/drawing/2014/main" id="{E39A1ECA-E4E9-DCD1-1445-B9B27E4EF0BC}"/>
+                <a16:creationId xmlns:a16="http://schemas.microsoft.com/office/drawing/2014/main" id="{CAA0D37F-2204-3596-758F-19F05DE25BA0}"/>
               </a:ext>
             </a:extLst>
           </p:cNvPr>
@@ -5463,7 +6071,11 @@
           <a:p>
             <a:r>
               <a:rPr lang="en-US" dirty="0"/>
-              <a:t>1 - G</a:t>
+              <a:t>1 - </a:t>
+            </a:r>
+            <a:r>
+              <a:rPr lang="en-US" i="1" dirty="0"/>
+              <a:t>g</a:t>
             </a:r>
           </a:p>
         </p:txBody>
@@ -5473,7 +6085,7 @@
           <p:cNvPr id="24" name="TextBox 23">
             <a:extLst>
               <a:ext uri="{FF2B5EF4-FFF2-40B4-BE49-F238E27FC236}">
-                <a16:creationId xmlns:a16="http://schemas.microsoft.com/office/drawing/2014/main" id="{A3D165A8-8646-5826-22E5-DF88B2194BF9}"/>
+                <a16:creationId xmlns:a16="http://schemas.microsoft.com/office/drawing/2014/main" id="{4D932E29-B15A-0F86-47DE-1C03AB5059D8}"/>
               </a:ext>
             </a:extLst>
           </p:cNvPr>
@@ -5498,7 +6110,11 @@
           <a:p>
             <a:r>
               <a:rPr lang="en-US" dirty="0"/>
-              <a:t>1 - a</a:t>
+              <a:t>1 - </a:t>
+            </a:r>
+            <a:r>
+              <a:rPr lang="en-US" i="1" dirty="0"/>
+              <a:t>a</a:t>
             </a:r>
           </a:p>
         </p:txBody>
@@ -5508,7 +6124,7 @@
           <p:cNvPr id="25" name="TextBox 24">
             <a:extLst>
               <a:ext uri="{FF2B5EF4-FFF2-40B4-BE49-F238E27FC236}">
-                <a16:creationId xmlns:a16="http://schemas.microsoft.com/office/drawing/2014/main" id="{E509FD53-37DE-26A8-5DD4-DA1EB230ADF5}"/>
+                <a16:creationId xmlns:a16="http://schemas.microsoft.com/office/drawing/2014/main" id="{DC543F71-75D9-7454-FEE6-2F54A1521E8B}"/>
               </a:ext>
             </a:extLst>
           </p:cNvPr>
@@ -5532,7 +6148,7 @@
           <a:lstStyle/>
           <a:p>
             <a:r>
-              <a:rPr lang="en-US" dirty="0"/>
+              <a:rPr lang="en-US" i="1" dirty="0"/>
               <a:t>a</a:t>
             </a:r>
           </a:p>
@@ -5543,7 +6159,7 @@
           <p:cNvPr id="26" name="Straight Connector 25">
             <a:extLst>
               <a:ext uri="{FF2B5EF4-FFF2-40B4-BE49-F238E27FC236}">
-                <a16:creationId xmlns:a16="http://schemas.microsoft.com/office/drawing/2014/main" id="{7CA0D0FB-D9F0-A595-2BC0-6085EFDB67B8}"/>
+                <a16:creationId xmlns:a16="http://schemas.microsoft.com/office/drawing/2014/main" id="{E6DBAAFF-C364-80EA-043E-02F6FC86743E}"/>
               </a:ext>
             </a:extLst>
           </p:cNvPr>
@@ -5584,7 +6200,7 @@
           <p:cNvPr id="27" name="Straight Connector 26">
             <a:extLst>
               <a:ext uri="{FF2B5EF4-FFF2-40B4-BE49-F238E27FC236}">
-                <a16:creationId xmlns:a16="http://schemas.microsoft.com/office/drawing/2014/main" id="{0AD2F898-E58B-3090-DDDB-132EBB76D1B5}"/>
+                <a16:creationId xmlns:a16="http://schemas.microsoft.com/office/drawing/2014/main" id="{3C0DAE73-CC46-6F7C-7241-870D6EAA3E1B}"/>
               </a:ext>
             </a:extLst>
           </p:cNvPr>
@@ -5625,7 +6241,7 @@
           <p:cNvPr id="28" name="Straight Connector 27">
             <a:extLst>
               <a:ext uri="{FF2B5EF4-FFF2-40B4-BE49-F238E27FC236}">
-                <a16:creationId xmlns:a16="http://schemas.microsoft.com/office/drawing/2014/main" id="{89C94E4F-8DA4-765D-D3FF-29562F6DBE7E}"/>
+                <a16:creationId xmlns:a16="http://schemas.microsoft.com/office/drawing/2014/main" id="{B55EC327-EAE2-920C-2373-156F3C7B1295}"/>
               </a:ext>
             </a:extLst>
           </p:cNvPr>
@@ -5668,7 +6284,7 @@
           <p:cNvPr id="29" name="Straight Connector 28">
             <a:extLst>
               <a:ext uri="{FF2B5EF4-FFF2-40B4-BE49-F238E27FC236}">
-                <a16:creationId xmlns:a16="http://schemas.microsoft.com/office/drawing/2014/main" id="{DFC112B5-681E-0646-73E4-312EC8A0CEEA}"/>
+                <a16:creationId xmlns:a16="http://schemas.microsoft.com/office/drawing/2014/main" id="{FD1BC091-52A3-DA68-1704-CD34A5D3043E}"/>
               </a:ext>
             </a:extLst>
           </p:cNvPr>
@@ -5711,7 +6327,7 @@
           <p:cNvPr id="30" name="TextBox 29">
             <a:extLst>
               <a:ext uri="{FF2B5EF4-FFF2-40B4-BE49-F238E27FC236}">
-                <a16:creationId xmlns:a16="http://schemas.microsoft.com/office/drawing/2014/main" id="{E23AD314-1221-79D3-C6F4-875450BA3EAA}"/>
+                <a16:creationId xmlns:a16="http://schemas.microsoft.com/office/drawing/2014/main" id="{75E168CF-F6D8-5EBA-7ED1-841DCBA5E642}"/>
               </a:ext>
             </a:extLst>
           </p:cNvPr>
@@ -5746,7 +6362,7 @@
           <p:cNvPr id="31" name="TextBox 30">
             <a:extLst>
               <a:ext uri="{FF2B5EF4-FFF2-40B4-BE49-F238E27FC236}">
-                <a16:creationId xmlns:a16="http://schemas.microsoft.com/office/drawing/2014/main" id="{AAA605C3-9941-BA85-9C25-6A504B77BD78}"/>
+                <a16:creationId xmlns:a16="http://schemas.microsoft.com/office/drawing/2014/main" id="{4191D848-DDF3-16E6-7459-EAF3E295A622}"/>
               </a:ext>
             </a:extLst>
           </p:cNvPr>
@@ -5781,7 +6397,7 @@
           <p:cNvPr id="32" name="TextBox 31">
             <a:extLst>
               <a:ext uri="{FF2B5EF4-FFF2-40B4-BE49-F238E27FC236}">
-                <a16:creationId xmlns:a16="http://schemas.microsoft.com/office/drawing/2014/main" id="{224A7FF7-0CE1-B1B0-218E-D23FC631C598}"/>
+                <a16:creationId xmlns:a16="http://schemas.microsoft.com/office/drawing/2014/main" id="{546BE473-DFB4-4D84-6FCF-98ED497AC750}"/>
               </a:ext>
             </a:extLst>
           </p:cNvPr>
@@ -5805,8 +6421,8 @@
           <a:lstStyle/>
           <a:p>
             <a:r>
-              <a:rPr lang="en-US" dirty="0"/>
-              <a:t>G</a:t>
+              <a:rPr lang="en-US" i="1" dirty="0"/>
+              <a:t>g</a:t>
             </a:r>
           </a:p>
         </p:txBody>
@@ -5816,7 +6432,7 @@
           <p:cNvPr id="33" name="TextBox 32">
             <a:extLst>
               <a:ext uri="{FF2B5EF4-FFF2-40B4-BE49-F238E27FC236}">
-                <a16:creationId xmlns:a16="http://schemas.microsoft.com/office/drawing/2014/main" id="{A63981C5-FE26-C526-AF0D-2F2C5B7A7803}"/>
+                <a16:creationId xmlns:a16="http://schemas.microsoft.com/office/drawing/2014/main" id="{4695A7DD-098B-A72D-1C04-B5A016F446F6}"/>
               </a:ext>
             </a:extLst>
           </p:cNvPr>
@@ -5841,7 +6457,11 @@
           <a:p>
             <a:r>
               <a:rPr lang="en-US" dirty="0"/>
-              <a:t>1 - G</a:t>
+              <a:t>1 - </a:t>
+            </a:r>
+            <a:r>
+              <a:rPr lang="en-US" i="1" dirty="0"/>
+              <a:t>g</a:t>
             </a:r>
           </a:p>
         </p:txBody>
@@ -5851,7 +6471,7 @@
           <p:cNvPr id="34" name="TextBox 33">
             <a:extLst>
               <a:ext uri="{FF2B5EF4-FFF2-40B4-BE49-F238E27FC236}">
-                <a16:creationId xmlns:a16="http://schemas.microsoft.com/office/drawing/2014/main" id="{5DA199C6-549A-484A-A49A-03C1E4D88B3A}"/>
+                <a16:creationId xmlns:a16="http://schemas.microsoft.com/office/drawing/2014/main" id="{C79E416B-4F87-8D92-08C7-8AC99F457150}"/>
               </a:ext>
             </a:extLst>
           </p:cNvPr>
@@ -5876,7 +6496,11 @@
           <a:p>
             <a:r>
               <a:rPr lang="en-US" dirty="0"/>
-              <a:t>1 - a</a:t>
+              <a:t>1 - </a:t>
+            </a:r>
+            <a:r>
+              <a:rPr lang="en-US" i="1" dirty="0"/>
+              <a:t>a</a:t>
             </a:r>
           </a:p>
         </p:txBody>
@@ -5886,7 +6510,7 @@
           <p:cNvPr id="35" name="TextBox 34">
             <a:extLst>
               <a:ext uri="{FF2B5EF4-FFF2-40B4-BE49-F238E27FC236}">
-                <a16:creationId xmlns:a16="http://schemas.microsoft.com/office/drawing/2014/main" id="{43357499-7B84-B158-5A13-2A16C78D0E53}"/>
+                <a16:creationId xmlns:a16="http://schemas.microsoft.com/office/drawing/2014/main" id="{06EDC515-B662-C955-FBD6-91A6B0DCF936}"/>
               </a:ext>
             </a:extLst>
           </p:cNvPr>
@@ -5910,7 +6534,7 @@
           <a:lstStyle/>
           <a:p>
             <a:r>
-              <a:rPr lang="en-US" dirty="0"/>
+              <a:rPr lang="en-US" i="1" dirty="0"/>
               <a:t>a</a:t>
             </a:r>
           </a:p>
@@ -5919,7 +6543,7 @@
     </p:spTree>
     <p:extLst>
       <p:ext uri="{BB962C8B-B14F-4D97-AF65-F5344CB8AC3E}">
-        <p14:creationId xmlns:p14="http://schemas.microsoft.com/office/powerpoint/2010/main" val="791694449"/>
+        <p14:creationId xmlns:p14="http://schemas.microsoft.com/office/powerpoint/2010/main" val="2058113189"/>
       </p:ext>
     </p:extLst>
   </p:cSld>

</xml_diff>